<commit_message>
Measure every poster text and keep the PowerPoint posters to the same rules
A long title ran over the header rule and a long reference reached the separator line. Both builders now measure every text: a statement may push its figures down, while a title block, a reference or a contact line that does not fit its space stops the build with an error that names it. The PowerPoint builder measures with the bundled Geist faces, sets the LaTeX line pitch as an exact spacing, converts design units with 72 points per inch, and spaces the header lines as LaTeX does; figures in the light look fill their box in both builders. The placeholder figure is a file in the package, so the template build does not depend on the PNG encoder. The tests check every text, the colours of ground, header and rule, statements that push their figures, text that does not fit, figure aspects, panels and type sizes, and the CI LaTeX job runs the new compile tests.
</commit_message>
<xml_diff>
--- a/templates/Forming Worlds Poster (a0landscape).pptx
+++ b/templates/Forming Worlds Poster (a0landscape).pptx
@@ -3218,7 +3218,7 @@
         <p:spPr>
           <a:xfrm>
             <a:off x="1210863" y="908147"/>
-            <a:ext cx="29253234" cy="4843451"/>
+            <a:ext cx="30464097" cy="2865507"/>
           </a:xfrm>
           <a:prstGeom prst="rect">
             <a:avLst/>
@@ -3226,13 +3226,21 @@
           <a:noFill/>
         </p:spPr>
         <p:txBody>
-          <a:bodyPr wrap="square" anchor="t" lIns="0" rIns="0" tIns="0" bIns="0">
+          <a:bodyPr wrap="square" lIns="0" rIns="0" tIns="0" bIns="0">
             <a:spAutoFit/>
           </a:bodyPr>
           <a:lstStyle/>
           <a:p>
-            <a:r>
-              <a:rPr sz="11010">
+            <a:pPr>
+              <a:lnSpc>
+                <a:spcPts val="11840"/>
+              </a:lnSpc>
+              <a:spcBef>
+                <a:spcPts val="0"/>
+              </a:spcBef>
+            </a:pPr>
+            <a:r>
+              <a:rPr sz="10960">
                 <a:solidFill>
                   <a:srgbClr val="FFFFFF"/>
                 </a:solidFill>
@@ -3242,8 +3250,16 @@
             </a:r>
           </a:p>
           <a:p>
-            <a:r>
-              <a:rPr sz="4840">
+            <a:pPr>
+              <a:lnSpc>
+                <a:spcPts val="5550"/>
+              </a:lnSpc>
+              <a:spcBef>
+                <a:spcPts val="2860"/>
+              </a:spcBef>
+            </a:pPr>
+            <a:r>
+              <a:rPr sz="4820">
                 <a:solidFill>
                   <a:srgbClr val="FFFFFF"/>
                 </a:solidFill>
@@ -3253,8 +3269,16 @@
             </a:r>
           </a:p>
           <a:p>
-            <a:r>
-              <a:rPr sz="3960">
+            <a:pPr>
+              <a:lnSpc>
+                <a:spcPts val="4540"/>
+              </a:lnSpc>
+              <a:spcBef>
+                <a:spcPts val="950"/>
+              </a:spcBef>
+            </a:pPr>
+            <a:r>
+              <a:rPr sz="3950">
                 <a:solidFill>
                   <a:srgbClr val="ABB2B8"/>
                 </a:solidFill>
@@ -3267,20 +3291,106 @@
       </p:sp>
       <p:sp>
         <p:nvSpPr>
-          <p:cNvPr id="6" name="Rectangle 5"/>
+          <p:cNvPr id="6" name="TextBox 5"/>
+          <p:cNvSpPr txBox="1"/>
+          <p:nvPr/>
+        </p:nvSpPr>
+        <p:spPr>
+          <a:xfrm>
+            <a:off x="1210863" y="6962461"/>
+            <a:ext cx="1356166" cy="1695208"/>
+          </a:xfrm>
+          <a:prstGeom prst="rect">
+            <a:avLst/>
+          </a:prstGeom>
+          <a:noFill/>
+        </p:spPr>
+        <p:txBody>
+          <a:bodyPr wrap="square" lIns="0" rIns="0" tIns="0" bIns="0">
+            <a:spAutoFit/>
+          </a:bodyPr>
+          <a:lstStyle/>
+          <a:p>
+            <a:pPr>
+              <a:lnSpc>
+                <a:spcPts val="12680"/>
+              </a:lnSpc>
+              <a:spcBef>
+                <a:spcPts val="0"/>
+              </a:spcBef>
+            </a:pPr>
+            <a:r>
+              <a:rPr sz="12680">
+                <a:solidFill>
+                  <a:srgbClr val="4DAAD8"/>
+                </a:solidFill>
+                <a:latin typeface="Geist Light"/>
+              </a:rPr>
+              <a:t>1</a:t>
+            </a:r>
+          </a:p>
+        </p:txBody>
+      </p:sp>
+      <p:sp>
+        <p:nvSpPr>
+          <p:cNvPr id="7" name="TextBox 6"/>
+          <p:cNvSpPr txBox="1"/>
+          <p:nvPr/>
+        </p:nvSpPr>
+        <p:spPr>
+          <a:xfrm>
+            <a:off x="2567029" y="7174362"/>
+            <a:ext cx="11418436" cy="1754540"/>
+          </a:xfrm>
+          <a:prstGeom prst="rect">
+            <a:avLst/>
+          </a:prstGeom>
+          <a:noFill/>
+        </p:spPr>
+        <p:txBody>
+          <a:bodyPr wrap="square" lIns="0" rIns="0" tIns="0" bIns="0">
+            <a:spAutoFit/>
+          </a:bodyPr>
+          <a:lstStyle/>
+          <a:p>
+            <a:pPr>
+              <a:lnSpc>
+                <a:spcPts val="7470"/>
+              </a:lnSpc>
+              <a:spcBef>
+                <a:spcPts val="0"/>
+              </a:spcBef>
+            </a:pPr>
+            <a:r>
+              <a:rPr sz="6670">
+                <a:solidFill>
+                  <a:srgbClr val="FFFFFF"/>
+                </a:solidFill>
+                <a:latin typeface="Geist Medium"/>
+              </a:rPr>
+              <a:t>First message as one statement</a:t>
+            </a:r>
+          </a:p>
+        </p:txBody>
+      </p:sp>
+      <p:sp>
+        <p:nvSpPr>
+          <p:cNvPr id="8" name="Rounded Rectangle 7"/>
           <p:cNvSpPr/>
           <p:nvPr/>
         </p:nvSpPr>
         <p:spPr>
           <a:xfrm>
-            <a:off x="14469810" y="6962461"/>
-            <a:ext cx="30272" cy="21194529"/>
-          </a:xfrm>
-          <a:prstGeom prst="rect">
-            <a:avLst/>
+            <a:off x="1510596" y="10540561"/>
+            <a:ext cx="12175137" cy="7791090"/>
+          </a:xfrm>
+          <a:prstGeom prst="roundRect">
+            <a:avLst>
+              <a:gd name="adj" fmla="val 3108"/>
+            </a:avLst>
           </a:prstGeom>
           <a:solidFill>
-            <a:srgbClr val="2A343C"/>
+            <a:srgbClr val="FFFFFF"/>
           </a:solidFill>
           <a:ln>
             <a:noFill/>
@@ -3309,16 +3419,40 @@
           </a:p>
         </p:txBody>
       </p:sp>
-      <p:sp>
-        <p:nvSpPr>
-          <p:cNvPr id="7" name="TextBox 6"/>
+      <p:pic>
+        <p:nvPicPr>
+          <p:cNvPr id="9" name="Picture 8" descr="poster-placeholder.png"/>
+          <p:cNvPicPr>
+            <a:picLocks noChangeAspect="1"/>
+          </p:cNvPicPr>
+          <p:nvPr/>
+        </p:nvPicPr>
+        <p:blipFill>
+          <a:blip r:embed="rId3"/>
+          <a:stretch>
+            <a:fillRect/>
+          </a:stretch>
+        </p:blipFill>
+        <p:spPr>
+          <a:xfrm>
+            <a:off x="1752768" y="10782733"/>
+            <a:ext cx="11690792" cy="7306745"/>
+          </a:xfrm>
+          <a:prstGeom prst="rect">
+            <a:avLst/>
+          </a:prstGeom>
+        </p:spPr>
+      </p:pic>
+      <p:sp>
+        <p:nvSpPr>
+          <p:cNvPr id="10" name="TextBox 9"/>
           <p:cNvSpPr txBox="1"/>
           <p:nvPr/>
         </p:nvSpPr>
         <p:spPr>
           <a:xfrm>
-            <a:off x="1210863" y="6962461"/>
-            <a:ext cx="1356166" cy="1695208"/>
+            <a:off x="1210863" y="18513280"/>
+            <a:ext cx="12774603" cy="714409"/>
           </a:xfrm>
           <a:prstGeom prst="rect">
             <a:avLst/>
@@ -3326,71 +3460,45 @@
           <a:noFill/>
         </p:spPr>
         <p:txBody>
-          <a:bodyPr wrap="square" anchor="t" lIns="0" rIns="0" tIns="0" bIns="0">
+          <a:bodyPr wrap="square" lIns="0" rIns="0" tIns="0" bIns="0">
             <a:spAutoFit/>
           </a:bodyPr>
           <a:lstStyle/>
           <a:p>
-            <a:r>
-              <a:rPr sz="12730">
+            <a:pPr>
+              <a:lnSpc>
+                <a:spcPts val="3840"/>
+              </a:lnSpc>
+              <a:spcBef>
+                <a:spcPts val="0"/>
+              </a:spcBef>
+            </a:pPr>
+            <a:r>
+              <a:rPr sz="3340">
                 <a:solidFill>
-                  <a:srgbClr val="4DAAD8"/>
+                  <a:srgbClr val="ABB2B8"/>
                 </a:solidFill>
-                <a:latin typeface="Geist Light"/>
+                <a:latin typeface="Geist"/>
               </a:rPr>
-              <a:t>1</a:t>
-            </a:r>
-          </a:p>
-        </p:txBody>
-      </p:sp>
-      <p:sp>
-        <p:nvSpPr>
-          <p:cNvPr id="8" name="TextBox 7"/>
-          <p:cNvSpPr txBox="1"/>
-          <p:nvPr/>
-        </p:nvSpPr>
-        <p:spPr>
-          <a:xfrm>
-            <a:off x="2567029" y="7174362"/>
-            <a:ext cx="11418436" cy="2203770"/>
-          </a:xfrm>
-          <a:prstGeom prst="rect">
-            <a:avLst/>
-          </a:prstGeom>
-          <a:noFill/>
-        </p:spPr>
-        <p:txBody>
-          <a:bodyPr wrap="square" anchor="t" lIns="0" rIns="0" tIns="0" bIns="0">
-            <a:spAutoFit/>
-          </a:bodyPr>
-          <a:lstStyle/>
-          <a:p>
-            <a:r>
-              <a:rPr sz="6700">
-                <a:solidFill>
-                  <a:srgbClr val="FFFFFF"/>
-                </a:solidFill>
-                <a:latin typeface="Geist Medium"/>
-              </a:rPr>
-              <a:t>First message as one statement</a:t>
-            </a:r>
-          </a:p>
-        </p:txBody>
-      </p:sp>
-      <p:sp>
-        <p:nvSpPr>
-          <p:cNvPr id="9" name="Rounded Rectangle 8"/>
+              <a:t>Author+ YY Journal</a:t>
+            </a:r>
+          </a:p>
+        </p:txBody>
+      </p:sp>
+      <p:sp>
+        <p:nvSpPr>
+          <p:cNvPr id="11" name="Rounded Rectangle 10"/>
           <p:cNvSpPr/>
           <p:nvPr/>
         </p:nvSpPr>
         <p:spPr>
           <a:xfrm>
-            <a:off x="1425835" y="10328660"/>
-            <a:ext cx="12344658" cy="7897040"/>
+            <a:off x="1510596" y="19348775"/>
+            <a:ext cx="12175137" cy="7791090"/>
           </a:xfrm>
           <a:prstGeom prst="roundRect">
             <a:avLst>
-              <a:gd name="adj" fmla="val 3066"/>
+              <a:gd name="adj" fmla="val 3108"/>
             </a:avLst>
           </a:prstGeom>
           <a:solidFill>
@@ -3425,7 +3533,7 @@
       </p:sp>
       <p:pic>
         <p:nvPicPr>
-          <p:cNvPr id="10" name="Picture 9" descr="image.png"/>
+          <p:cNvPr id="12" name="Picture 11" descr="poster-placeholder.png"/>
           <p:cNvPicPr>
             <a:picLocks noChangeAspect="1"/>
           </p:cNvPicPr>
@@ -3439,8 +3547,8 @@
         </p:blipFill>
         <p:spPr>
           <a:xfrm>
-            <a:off x="1668008" y="10570832"/>
-            <a:ext cx="11860313" cy="7412695"/>
+            <a:off x="1752768" y="19590948"/>
+            <a:ext cx="11690792" cy="7306745"/>
           </a:xfrm>
           <a:prstGeom prst="rect">
             <a:avLst/>
@@ -3449,14 +3557,14 @@
       </p:pic>
       <p:sp>
         <p:nvSpPr>
-          <p:cNvPr id="11" name="TextBox 10"/>
+          <p:cNvPr id="13" name="TextBox 12"/>
           <p:cNvSpPr txBox="1"/>
           <p:nvPr/>
         </p:nvSpPr>
         <p:spPr>
           <a:xfrm>
-            <a:off x="1210863" y="18407330"/>
-            <a:ext cx="12774603" cy="847604"/>
+            <a:off x="1210863" y="27321495"/>
+            <a:ext cx="12774603" cy="714409"/>
           </a:xfrm>
           <a:prstGeom prst="rect">
             <a:avLst/>
@@ -3464,41 +3572,47 @@
           <a:noFill/>
         </p:spPr>
         <p:txBody>
-          <a:bodyPr wrap="square" anchor="t" lIns="0" rIns="0" tIns="0" bIns="0">
+          <a:bodyPr wrap="square" lIns="0" rIns="0" tIns="0" bIns="0">
             <a:spAutoFit/>
           </a:bodyPr>
           <a:lstStyle/>
           <a:p>
-            <a:r>
-              <a:rPr sz="3350">
+            <a:pPr>
+              <a:lnSpc>
+                <a:spcPts val="3840"/>
+              </a:lnSpc>
+              <a:spcBef>
+                <a:spcPts val="0"/>
+              </a:spcBef>
+            </a:pPr>
+            <a:r>
+              <a:rPr sz="3340">
                 <a:solidFill>
                   <a:srgbClr val="ABB2B8"/>
                 </a:solidFill>
                 <a:latin typeface="Geist"/>
               </a:rPr>
-              <a:t>Author+ YY Journal</a:t>
-            </a:r>
-          </a:p>
-        </p:txBody>
-      </p:sp>
-      <p:sp>
-        <p:nvSpPr>
-          <p:cNvPr id="12" name="Rounded Rectangle 11"/>
+              <a:t>Second+ YY Journal</a:t>
+            </a:r>
+          </a:p>
+        </p:txBody>
+      </p:sp>
+      <p:sp>
+        <p:nvSpPr>
+          <p:cNvPr id="14" name="Rectangle 13"/>
           <p:cNvSpPr/>
           <p:nvPr/>
         </p:nvSpPr>
         <p:spPr>
           <a:xfrm>
-            <a:off x="1425835" y="19242825"/>
-            <a:ext cx="12344658" cy="7897040"/>
-          </a:xfrm>
-          <a:prstGeom prst="roundRect">
-            <a:avLst>
-              <a:gd name="adj" fmla="val 3066"/>
-            </a:avLst>
+            <a:off x="14469810" y="6962461"/>
+            <a:ext cx="30272" cy="21194529"/>
+          </a:xfrm>
+          <a:prstGeom prst="rect">
+            <a:avLst/>
           </a:prstGeom>
           <a:solidFill>
-            <a:srgbClr val="FFFFFF"/>
+            <a:srgbClr val="2A343C"/>
           </a:solidFill>
           <a:ln>
             <a:noFill/>
@@ -3527,40 +3641,58 @@
           </a:p>
         </p:txBody>
       </p:sp>
-      <p:pic>
-        <p:nvPicPr>
-          <p:cNvPr id="13" name="Picture 12" descr="image.png"/>
-          <p:cNvPicPr>
-            <a:picLocks noChangeAspect="1"/>
-          </p:cNvPicPr>
+      <p:sp>
+        <p:nvSpPr>
+          <p:cNvPr id="15" name="TextBox 14"/>
+          <p:cNvSpPr txBox="1"/>
           <p:nvPr/>
-        </p:nvPicPr>
-        <p:blipFill>
-          <a:blip r:embed="rId3"/>
-          <a:stretch>
-            <a:fillRect/>
-          </a:stretch>
-        </p:blipFill>
-        <p:spPr>
-          <a:xfrm>
-            <a:off x="1668008" y="19484997"/>
-            <a:ext cx="11860313" cy="7412695"/>
+        </p:nvSpPr>
+        <p:spPr>
+          <a:xfrm>
+            <a:off x="15014699" y="6962461"/>
+            <a:ext cx="1356166" cy="1695208"/>
           </a:xfrm>
           <a:prstGeom prst="rect">
             <a:avLst/>
           </a:prstGeom>
-        </p:spPr>
-      </p:pic>
-      <p:sp>
-        <p:nvSpPr>
-          <p:cNvPr id="14" name="TextBox 13"/>
+          <a:noFill/>
+        </p:spPr>
+        <p:txBody>
+          <a:bodyPr wrap="square" lIns="0" rIns="0" tIns="0" bIns="0">
+            <a:spAutoFit/>
+          </a:bodyPr>
+          <a:lstStyle/>
+          <a:p>
+            <a:pPr>
+              <a:lnSpc>
+                <a:spcPts val="12680"/>
+              </a:lnSpc>
+              <a:spcBef>
+                <a:spcPts val="0"/>
+              </a:spcBef>
+            </a:pPr>
+            <a:r>
+              <a:rPr sz="12680">
+                <a:solidFill>
+                  <a:srgbClr val="4DAAD8"/>
+                </a:solidFill>
+                <a:latin typeface="Geist Light"/>
+              </a:rPr>
+              <a:t>2</a:t>
+            </a:r>
+          </a:p>
+        </p:txBody>
+      </p:sp>
+      <p:sp>
+        <p:nvSpPr>
+          <p:cNvPr id="16" name="TextBox 15"/>
           <p:cNvSpPr txBox="1"/>
           <p:nvPr/>
         </p:nvSpPr>
         <p:spPr>
           <a:xfrm>
-            <a:off x="1210863" y="27321495"/>
-            <a:ext cx="12774603" cy="847604"/>
+            <a:off x="16370865" y="7174362"/>
+            <a:ext cx="11418436" cy="1754540"/>
           </a:xfrm>
           <a:prstGeom prst="rect">
             <a:avLst/>
@@ -3568,39 +3700,49 @@
           <a:noFill/>
         </p:spPr>
         <p:txBody>
-          <a:bodyPr wrap="square" anchor="t" lIns="0" rIns="0" tIns="0" bIns="0">
+          <a:bodyPr wrap="square" lIns="0" rIns="0" tIns="0" bIns="0">
             <a:spAutoFit/>
           </a:bodyPr>
           <a:lstStyle/>
           <a:p>
-            <a:r>
-              <a:rPr sz="3350">
+            <a:pPr>
+              <a:lnSpc>
+                <a:spcPts val="7470"/>
+              </a:lnSpc>
+              <a:spcBef>
+                <a:spcPts val="0"/>
+              </a:spcBef>
+            </a:pPr>
+            <a:r>
+              <a:rPr sz="6670">
                 <a:solidFill>
-                  <a:srgbClr val="ABB2B8"/>
+                  <a:srgbClr val="FFFFFF"/>
                 </a:solidFill>
-                <a:latin typeface="Geist"/>
+                <a:latin typeface="Geist Medium"/>
               </a:rPr>
-              <a:t>Author+ YY Journal</a:t>
-            </a:r>
-          </a:p>
-        </p:txBody>
-      </p:sp>
-      <p:sp>
-        <p:nvSpPr>
-          <p:cNvPr id="15" name="Rectangle 14"/>
+              <a:t>Second message as one statement</a:t>
+            </a:r>
+          </a:p>
+        </p:txBody>
+      </p:sp>
+      <p:sp>
+        <p:nvSpPr>
+          <p:cNvPr id="17" name="Rounded Rectangle 16"/>
           <p:cNvSpPr/>
           <p:nvPr/>
         </p:nvSpPr>
         <p:spPr>
           <a:xfrm>
-            <a:off x="28273646" y="6962461"/>
-            <a:ext cx="30272" cy="21194529"/>
-          </a:xfrm>
-          <a:prstGeom prst="rect">
-            <a:avLst/>
+            <a:off x="15314432" y="10540561"/>
+            <a:ext cx="12175137" cy="7791090"/>
+          </a:xfrm>
+          <a:prstGeom prst="roundRect">
+            <a:avLst>
+              <a:gd name="adj" fmla="val 3108"/>
+            </a:avLst>
           </a:prstGeom>
           <a:solidFill>
-            <a:srgbClr val="2A343C"/>
+            <a:srgbClr val="FFFFFF"/>
           </a:solidFill>
           <a:ln>
             <a:noFill/>
@@ -3629,16 +3771,40 @@
           </a:p>
         </p:txBody>
       </p:sp>
-      <p:sp>
-        <p:nvSpPr>
-          <p:cNvPr id="16" name="TextBox 15"/>
+      <p:pic>
+        <p:nvPicPr>
+          <p:cNvPr id="18" name="Picture 17" descr="poster-placeholder.png"/>
+          <p:cNvPicPr>
+            <a:picLocks noChangeAspect="1"/>
+          </p:cNvPicPr>
+          <p:nvPr/>
+        </p:nvPicPr>
+        <p:blipFill>
+          <a:blip r:embed="rId3"/>
+          <a:stretch>
+            <a:fillRect/>
+          </a:stretch>
+        </p:blipFill>
+        <p:spPr>
+          <a:xfrm>
+            <a:off x="15556604" y="10782733"/>
+            <a:ext cx="11690792" cy="7306745"/>
+          </a:xfrm>
+          <a:prstGeom prst="rect">
+            <a:avLst/>
+          </a:prstGeom>
+        </p:spPr>
+      </p:pic>
+      <p:sp>
+        <p:nvSpPr>
+          <p:cNvPr id="19" name="TextBox 18"/>
           <p:cNvSpPr txBox="1"/>
           <p:nvPr/>
         </p:nvSpPr>
         <p:spPr>
           <a:xfrm>
-            <a:off x="15014699" y="6962461"/>
-            <a:ext cx="1356166" cy="1695208"/>
+            <a:off x="15014699" y="18513280"/>
+            <a:ext cx="12774603" cy="714409"/>
           </a:xfrm>
           <a:prstGeom prst="rect">
             <a:avLst/>
@@ -3646,71 +3812,45 @@
           <a:noFill/>
         </p:spPr>
         <p:txBody>
-          <a:bodyPr wrap="square" anchor="t" lIns="0" rIns="0" tIns="0" bIns="0">
+          <a:bodyPr wrap="square" lIns="0" rIns="0" tIns="0" bIns="0">
             <a:spAutoFit/>
           </a:bodyPr>
           <a:lstStyle/>
           <a:p>
-            <a:r>
-              <a:rPr sz="12730">
+            <a:pPr>
+              <a:lnSpc>
+                <a:spcPts val="3840"/>
+              </a:lnSpc>
+              <a:spcBef>
+                <a:spcPts val="0"/>
+              </a:spcBef>
+            </a:pPr>
+            <a:r>
+              <a:rPr sz="3340">
                 <a:solidFill>
-                  <a:srgbClr val="4DAAD8"/>
+                  <a:srgbClr val="ABB2B8"/>
                 </a:solidFill>
-                <a:latin typeface="Geist Light"/>
+                <a:latin typeface="Geist"/>
               </a:rPr>
-              <a:t>2</a:t>
-            </a:r>
-          </a:p>
-        </p:txBody>
-      </p:sp>
-      <p:sp>
-        <p:nvSpPr>
-          <p:cNvPr id="17" name="TextBox 16"/>
-          <p:cNvSpPr txBox="1"/>
-          <p:nvPr/>
-        </p:nvSpPr>
-        <p:spPr>
-          <a:xfrm>
-            <a:off x="16370865" y="7174362"/>
-            <a:ext cx="11418436" cy="2203770"/>
-          </a:xfrm>
-          <a:prstGeom prst="rect">
-            <a:avLst/>
-          </a:prstGeom>
-          <a:noFill/>
-        </p:spPr>
-        <p:txBody>
-          <a:bodyPr wrap="square" anchor="t" lIns="0" rIns="0" tIns="0" bIns="0">
-            <a:spAutoFit/>
-          </a:bodyPr>
-          <a:lstStyle/>
-          <a:p>
-            <a:r>
-              <a:rPr sz="6700">
-                <a:solidFill>
-                  <a:srgbClr val="FFFFFF"/>
-                </a:solidFill>
-                <a:latin typeface="Geist Medium"/>
-              </a:rPr>
-              <a:t>Second message as one statement</a:t>
-            </a:r>
-          </a:p>
-        </p:txBody>
-      </p:sp>
-      <p:sp>
-        <p:nvSpPr>
-          <p:cNvPr id="18" name="Rounded Rectangle 17"/>
+              <a:t>Third+ YY Journal</a:t>
+            </a:r>
+          </a:p>
+        </p:txBody>
+      </p:sp>
+      <p:sp>
+        <p:nvSpPr>
+          <p:cNvPr id="20" name="Rounded Rectangle 19"/>
           <p:cNvSpPr/>
           <p:nvPr/>
         </p:nvSpPr>
         <p:spPr>
           <a:xfrm>
-            <a:off x="15229671" y="10328660"/>
-            <a:ext cx="12344658" cy="7897040"/>
+            <a:off x="15314432" y="19348775"/>
+            <a:ext cx="12175137" cy="7791090"/>
           </a:xfrm>
           <a:prstGeom prst="roundRect">
             <a:avLst>
-              <a:gd name="adj" fmla="val 3066"/>
+              <a:gd name="adj" fmla="val 3108"/>
             </a:avLst>
           </a:prstGeom>
           <a:solidFill>
@@ -3745,7 +3885,7 @@
       </p:sp>
       <p:pic>
         <p:nvPicPr>
-          <p:cNvPr id="19" name="Picture 18" descr="image.png"/>
+          <p:cNvPr id="21" name="Picture 20" descr="poster-placeholder.png"/>
           <p:cNvPicPr>
             <a:picLocks noChangeAspect="1"/>
           </p:cNvPicPr>
@@ -3759,8 +3899,8 @@
         </p:blipFill>
         <p:spPr>
           <a:xfrm>
-            <a:off x="15471844" y="10570832"/>
-            <a:ext cx="11860313" cy="7412695"/>
+            <a:off x="15556604" y="19590948"/>
+            <a:ext cx="11690792" cy="7306745"/>
           </a:xfrm>
           <a:prstGeom prst="rect">
             <a:avLst/>
@@ -3769,14 +3909,14 @@
       </p:pic>
       <p:sp>
         <p:nvSpPr>
-          <p:cNvPr id="20" name="TextBox 19"/>
+          <p:cNvPr id="22" name="TextBox 21"/>
           <p:cNvSpPr txBox="1"/>
           <p:nvPr/>
         </p:nvSpPr>
         <p:spPr>
           <a:xfrm>
-            <a:off x="15014699" y="18407330"/>
-            <a:ext cx="12774603" cy="847604"/>
+            <a:off x="15014699" y="27321495"/>
+            <a:ext cx="12774603" cy="714409"/>
           </a:xfrm>
           <a:prstGeom prst="rect">
             <a:avLst/>
@@ -3784,41 +3924,47 @@
           <a:noFill/>
         </p:spPr>
         <p:txBody>
-          <a:bodyPr wrap="square" anchor="t" lIns="0" rIns="0" tIns="0" bIns="0">
+          <a:bodyPr wrap="square" lIns="0" rIns="0" tIns="0" bIns="0">
             <a:spAutoFit/>
           </a:bodyPr>
           <a:lstStyle/>
           <a:p>
-            <a:r>
-              <a:rPr sz="3350">
+            <a:pPr>
+              <a:lnSpc>
+                <a:spcPts val="3840"/>
+              </a:lnSpc>
+              <a:spcBef>
+                <a:spcPts val="0"/>
+              </a:spcBef>
+            </a:pPr>
+            <a:r>
+              <a:rPr sz="3340">
                 <a:solidFill>
                   <a:srgbClr val="ABB2B8"/>
                 </a:solidFill>
                 <a:latin typeface="Geist"/>
               </a:rPr>
-              <a:t>Author+ YY Journal</a:t>
-            </a:r>
-          </a:p>
-        </p:txBody>
-      </p:sp>
-      <p:sp>
-        <p:nvSpPr>
-          <p:cNvPr id="21" name="Rounded Rectangle 20"/>
+              <a:t>Fourth+ YY Journal</a:t>
+            </a:r>
+          </a:p>
+        </p:txBody>
+      </p:sp>
+      <p:sp>
+        <p:nvSpPr>
+          <p:cNvPr id="23" name="Rectangle 22"/>
           <p:cNvSpPr/>
           <p:nvPr/>
         </p:nvSpPr>
         <p:spPr>
           <a:xfrm>
-            <a:off x="15229671" y="19242825"/>
-            <a:ext cx="12344658" cy="7897040"/>
-          </a:xfrm>
-          <a:prstGeom prst="roundRect">
-            <a:avLst>
-              <a:gd name="adj" fmla="val 3066"/>
-            </a:avLst>
+            <a:off x="28273646" y="6962461"/>
+            <a:ext cx="30272" cy="21194529"/>
+          </a:xfrm>
+          <a:prstGeom prst="rect">
+            <a:avLst/>
           </a:prstGeom>
           <a:solidFill>
-            <a:srgbClr val="FFFFFF"/>
+            <a:srgbClr val="2A343C"/>
           </a:solidFill>
           <a:ln>
             <a:noFill/>
@@ -3847,64 +3993,6 @@
           </a:p>
         </p:txBody>
       </p:sp>
-      <p:pic>
-        <p:nvPicPr>
-          <p:cNvPr id="22" name="Picture 21" descr="image.png"/>
-          <p:cNvPicPr>
-            <a:picLocks noChangeAspect="1"/>
-          </p:cNvPicPr>
-          <p:nvPr/>
-        </p:nvPicPr>
-        <p:blipFill>
-          <a:blip r:embed="rId3"/>
-          <a:stretch>
-            <a:fillRect/>
-          </a:stretch>
-        </p:blipFill>
-        <p:spPr>
-          <a:xfrm>
-            <a:off x="15471844" y="19484997"/>
-            <a:ext cx="11860313" cy="7412695"/>
-          </a:xfrm>
-          <a:prstGeom prst="rect">
-            <a:avLst/>
-          </a:prstGeom>
-        </p:spPr>
-      </p:pic>
-      <p:sp>
-        <p:nvSpPr>
-          <p:cNvPr id="23" name="TextBox 22"/>
-          <p:cNvSpPr txBox="1"/>
-          <p:nvPr/>
-        </p:nvSpPr>
-        <p:spPr>
-          <a:xfrm>
-            <a:off x="15014699" y="27321495"/>
-            <a:ext cx="12774603" cy="847604"/>
-          </a:xfrm>
-          <a:prstGeom prst="rect">
-            <a:avLst/>
-          </a:prstGeom>
-          <a:noFill/>
-        </p:spPr>
-        <p:txBody>
-          <a:bodyPr wrap="square" anchor="t" lIns="0" rIns="0" tIns="0" bIns="0">
-            <a:spAutoFit/>
-          </a:bodyPr>
-          <a:lstStyle/>
-          <a:p>
-            <a:r>
-              <a:rPr sz="3350">
-                <a:solidFill>
-                  <a:srgbClr val="ABB2B8"/>
-                </a:solidFill>
-                <a:latin typeface="Geist"/>
-              </a:rPr>
-              <a:t>Author+ YY Journal</a:t>
-            </a:r>
-          </a:p>
-        </p:txBody>
-      </p:sp>
       <p:sp>
         <p:nvSpPr>
           <p:cNvPr id="24" name="TextBox 23"/>
@@ -3922,13 +4010,21 @@
           <a:noFill/>
         </p:spPr>
         <p:txBody>
-          <a:bodyPr wrap="square" anchor="t" lIns="0" rIns="0" tIns="0" bIns="0">
+          <a:bodyPr wrap="square" lIns="0" rIns="0" tIns="0" bIns="0">
             <a:spAutoFit/>
           </a:bodyPr>
           <a:lstStyle/>
           <a:p>
-            <a:r>
-              <a:rPr sz="12730">
+            <a:pPr>
+              <a:lnSpc>
+                <a:spcPts val="12680"/>
+              </a:lnSpc>
+              <a:spcBef>
+                <a:spcPts val="0"/>
+              </a:spcBef>
+            </a:pPr>
+            <a:r>
+              <a:rPr sz="12680">
                 <a:solidFill>
                   <a:srgbClr val="4DAAD8"/>
                 </a:solidFill>
@@ -3948,7 +4044,7 @@
         <p:spPr>
           <a:xfrm>
             <a:off x="30174701" y="7174362"/>
-            <a:ext cx="11418436" cy="2203770"/>
+            <a:ext cx="11418436" cy="1754540"/>
           </a:xfrm>
           <a:prstGeom prst="rect">
             <a:avLst/>
@@ -3956,13 +4052,21 @@
           <a:noFill/>
         </p:spPr>
         <p:txBody>
-          <a:bodyPr wrap="square" anchor="t" lIns="0" rIns="0" tIns="0" bIns="0">
+          <a:bodyPr wrap="square" lIns="0" rIns="0" tIns="0" bIns="0">
             <a:spAutoFit/>
           </a:bodyPr>
           <a:lstStyle/>
           <a:p>
-            <a:r>
-              <a:rPr sz="6700">
+            <a:pPr>
+              <a:lnSpc>
+                <a:spcPts val="7470"/>
+              </a:lnSpc>
+              <a:spcBef>
+                <a:spcPts val="0"/>
+              </a:spcBef>
+            </a:pPr>
+            <a:r>
+              <a:rPr sz="6670">
                 <a:solidFill>
                   <a:srgbClr val="FFFFFF"/>
                 </a:solidFill>
@@ -3981,12 +4085,12 @@
         </p:nvSpPr>
         <p:spPr>
           <a:xfrm>
-            <a:off x="29033507" y="10328660"/>
-            <a:ext cx="12344658" cy="7897040"/>
+            <a:off x="29118267" y="10540561"/>
+            <a:ext cx="12175137" cy="7791090"/>
           </a:xfrm>
           <a:prstGeom prst="roundRect">
             <a:avLst>
-              <a:gd name="adj" fmla="val 3066"/>
+              <a:gd name="adj" fmla="val 3108"/>
             </a:avLst>
           </a:prstGeom>
           <a:solidFill>
@@ -4021,7 +4125,7 @@
       </p:sp>
       <p:pic>
         <p:nvPicPr>
-          <p:cNvPr id="27" name="Picture 26" descr="image.png"/>
+          <p:cNvPr id="27" name="Picture 26" descr="poster-placeholder.png"/>
           <p:cNvPicPr>
             <a:picLocks noChangeAspect="1"/>
           </p:cNvPicPr>
@@ -4035,8 +4139,8 @@
         </p:blipFill>
         <p:spPr>
           <a:xfrm>
-            <a:off x="29275680" y="10570832"/>
-            <a:ext cx="11860313" cy="7412695"/>
+            <a:off x="29360440" y="10782733"/>
+            <a:ext cx="11690792" cy="7306745"/>
           </a:xfrm>
           <a:prstGeom prst="rect">
             <a:avLst/>
@@ -4051,8 +4155,8 @@
         </p:nvSpPr>
         <p:spPr>
           <a:xfrm>
-            <a:off x="28818535" y="18407330"/>
-            <a:ext cx="12774603" cy="847604"/>
+            <a:off x="28818535" y="18513280"/>
+            <a:ext cx="12774603" cy="714409"/>
           </a:xfrm>
           <a:prstGeom prst="rect">
             <a:avLst/>
@@ -4060,19 +4164,27 @@
           <a:noFill/>
         </p:spPr>
         <p:txBody>
-          <a:bodyPr wrap="square" anchor="t" lIns="0" rIns="0" tIns="0" bIns="0">
+          <a:bodyPr wrap="square" lIns="0" rIns="0" tIns="0" bIns="0">
             <a:spAutoFit/>
           </a:bodyPr>
           <a:lstStyle/>
           <a:p>
-            <a:r>
-              <a:rPr sz="3350">
+            <a:pPr>
+              <a:lnSpc>
+                <a:spcPts val="3840"/>
+              </a:lnSpc>
+              <a:spcBef>
+                <a:spcPts val="0"/>
+              </a:spcBef>
+            </a:pPr>
+            <a:r>
+              <a:rPr sz="3340">
                 <a:solidFill>
                   <a:srgbClr val="ABB2B8"/>
                 </a:solidFill>
                 <a:latin typeface="Geist"/>
               </a:rPr>
-              <a:t>Author+ YY Journal</a:t>
+              <a:t>Fifth+ YY Journal</a:t>
             </a:r>
           </a:p>
         </p:txBody>
@@ -4085,12 +4197,12 @@
         </p:nvSpPr>
         <p:spPr>
           <a:xfrm>
-            <a:off x="29033507" y="19242825"/>
-            <a:ext cx="12344658" cy="7897040"/>
+            <a:off x="29118267" y="19348775"/>
+            <a:ext cx="12175137" cy="7791090"/>
           </a:xfrm>
           <a:prstGeom prst="roundRect">
             <a:avLst>
-              <a:gd name="adj" fmla="val 3066"/>
+              <a:gd name="adj" fmla="val 3108"/>
             </a:avLst>
           </a:prstGeom>
           <a:solidFill>
@@ -4125,7 +4237,7 @@
       </p:sp>
       <p:pic>
         <p:nvPicPr>
-          <p:cNvPr id="30" name="Picture 29" descr="image.png"/>
+          <p:cNvPr id="30" name="Picture 29" descr="poster-placeholder.png"/>
           <p:cNvPicPr>
             <a:picLocks noChangeAspect="1"/>
           </p:cNvPicPr>
@@ -4139,8 +4251,8 @@
         </p:blipFill>
         <p:spPr>
           <a:xfrm>
-            <a:off x="29275680" y="19484997"/>
-            <a:ext cx="11860313" cy="7412695"/>
+            <a:off x="29360440" y="19590948"/>
+            <a:ext cx="11690792" cy="7306745"/>
           </a:xfrm>
           <a:prstGeom prst="rect">
             <a:avLst/>
@@ -4156,7 +4268,7 @@
         <p:spPr>
           <a:xfrm>
             <a:off x="28818535" y="27321495"/>
-            <a:ext cx="12774603" cy="847604"/>
+            <a:ext cx="12774603" cy="714409"/>
           </a:xfrm>
           <a:prstGeom prst="rect">
             <a:avLst/>
@@ -4164,19 +4276,27 @@
           <a:noFill/>
         </p:spPr>
         <p:txBody>
-          <a:bodyPr wrap="square" anchor="t" lIns="0" rIns="0" tIns="0" bIns="0">
+          <a:bodyPr wrap="square" lIns="0" rIns="0" tIns="0" bIns="0">
             <a:spAutoFit/>
           </a:bodyPr>
           <a:lstStyle/>
           <a:p>
-            <a:r>
-              <a:rPr sz="3350">
+            <a:pPr>
+              <a:lnSpc>
+                <a:spcPts val="3840"/>
+              </a:lnSpc>
+              <a:spcBef>
+                <a:spcPts val="0"/>
+              </a:spcBef>
+            </a:pPr>
+            <a:r>
+              <a:rPr sz="3340">
                 <a:solidFill>
                   <a:srgbClr val="ABB2B8"/>
                 </a:solidFill>
                 <a:latin typeface="Geist"/>
               </a:rPr>
-              <a:t>Author+ YY Journal</a:t>
+              <a:t>Sixth+ YY Journal</a:t>
             </a:r>
           </a:p>
         </p:txBody>
@@ -4189,8 +4309,8 @@
         </p:nvSpPr>
         <p:spPr>
           <a:xfrm>
-            <a:off x="1210863" y="28871399"/>
-            <a:ext cx="40382274" cy="678083"/>
+            <a:off x="1210863" y="28990064"/>
+            <a:ext cx="40382274" cy="559419"/>
           </a:xfrm>
           <a:prstGeom prst="rect">
             <a:avLst/>
@@ -4198,13 +4318,21 @@
           <a:noFill/>
         </p:spPr>
         <p:txBody>
-          <a:bodyPr wrap="square" anchor="b" lIns="0" rIns="0" tIns="0" bIns="0">
+          <a:bodyPr wrap="square" lIns="0" rIns="0" tIns="0" bIns="0">
             <a:spAutoFit/>
           </a:bodyPr>
           <a:lstStyle/>
           <a:p>
-            <a:r>
-              <a:rPr sz="3850">
+            <a:pPr>
+              <a:lnSpc>
+                <a:spcPts val="4410"/>
+              </a:lnSpc>
+              <a:spcBef>
+                <a:spcPts val="0"/>
+              </a:spcBef>
+            </a:pPr>
+            <a:r>
+              <a:rPr sz="3840">
                 <a:solidFill>
                   <a:srgbClr val="ABB2B8"/>
                 </a:solidFill>
@@ -4362,7 +4490,7 @@
         <p:spPr>
           <a:xfrm>
             <a:off x="1210863" y="908147"/>
-            <a:ext cx="29253234" cy="4843451"/>
+            <a:ext cx="30464097" cy="2865507"/>
           </a:xfrm>
           <a:prstGeom prst="rect">
             <a:avLst/>
@@ -4370,13 +4498,21 @@
           <a:noFill/>
         </p:spPr>
         <p:txBody>
-          <a:bodyPr wrap="square" anchor="t" lIns="0" rIns="0" tIns="0" bIns="0">
+          <a:bodyPr wrap="square" lIns="0" rIns="0" tIns="0" bIns="0">
             <a:spAutoFit/>
           </a:bodyPr>
           <a:lstStyle/>
           <a:p>
-            <a:r>
-              <a:rPr sz="11010">
+            <a:pPr>
+              <a:lnSpc>
+                <a:spcPts val="11840"/>
+              </a:lnSpc>
+              <a:spcBef>
+                <a:spcPts val="0"/>
+              </a:spcBef>
+            </a:pPr>
+            <a:r>
+              <a:rPr sz="10960">
                 <a:solidFill>
                   <a:srgbClr val="010305"/>
                 </a:solidFill>
@@ -4386,8 +4522,16 @@
             </a:r>
           </a:p>
           <a:p>
-            <a:r>
-              <a:rPr sz="4840">
+            <a:pPr>
+              <a:lnSpc>
+                <a:spcPts val="5550"/>
+              </a:lnSpc>
+              <a:spcBef>
+                <a:spcPts val="2860"/>
+              </a:spcBef>
+            </a:pPr>
+            <a:r>
+              <a:rPr sz="4820">
                 <a:solidFill>
                   <a:srgbClr val="010305"/>
                 </a:solidFill>
@@ -4397,8 +4541,16 @@
             </a:r>
           </a:p>
           <a:p>
-            <a:r>
-              <a:rPr sz="3960">
+            <a:pPr>
+              <a:lnSpc>
+                <a:spcPts val="4540"/>
+              </a:lnSpc>
+              <a:spcBef>
+                <a:spcPts val="950"/>
+              </a:spcBef>
+            </a:pPr>
+            <a:r>
+              <a:rPr sz="3950">
                 <a:solidFill>
                   <a:srgbClr val="475159"/>
                 </a:solidFill>
@@ -4411,7 +4563,223 @@
       </p:sp>
       <p:sp>
         <p:nvSpPr>
-          <p:cNvPr id="6" name="Rectangle 5"/>
+          <p:cNvPr id="6" name="TextBox 5"/>
+          <p:cNvSpPr txBox="1"/>
+          <p:nvPr/>
+        </p:nvSpPr>
+        <p:spPr>
+          <a:xfrm>
+            <a:off x="1210863" y="6962461"/>
+            <a:ext cx="1356166" cy="1695208"/>
+          </a:xfrm>
+          <a:prstGeom prst="rect">
+            <a:avLst/>
+          </a:prstGeom>
+          <a:noFill/>
+        </p:spPr>
+        <p:txBody>
+          <a:bodyPr wrap="square" lIns="0" rIns="0" tIns="0" bIns="0">
+            <a:spAutoFit/>
+          </a:bodyPr>
+          <a:lstStyle/>
+          <a:p>
+            <a:pPr>
+              <a:lnSpc>
+                <a:spcPts val="12680"/>
+              </a:lnSpc>
+              <a:spcBef>
+                <a:spcPts val="0"/>
+              </a:spcBef>
+            </a:pPr>
+            <a:r>
+              <a:rPr sz="12680">
+                <a:solidFill>
+                  <a:srgbClr val="0072A1"/>
+                </a:solidFill>
+                <a:latin typeface="Geist Light"/>
+              </a:rPr>
+              <a:t>1</a:t>
+            </a:r>
+          </a:p>
+        </p:txBody>
+      </p:sp>
+      <p:sp>
+        <p:nvSpPr>
+          <p:cNvPr id="7" name="TextBox 6"/>
+          <p:cNvSpPr txBox="1"/>
+          <p:nvPr/>
+        </p:nvSpPr>
+        <p:spPr>
+          <a:xfrm>
+            <a:off x="2567029" y="7174362"/>
+            <a:ext cx="11418436" cy="1754540"/>
+          </a:xfrm>
+          <a:prstGeom prst="rect">
+            <a:avLst/>
+          </a:prstGeom>
+          <a:noFill/>
+        </p:spPr>
+        <p:txBody>
+          <a:bodyPr wrap="square" lIns="0" rIns="0" tIns="0" bIns="0">
+            <a:spAutoFit/>
+          </a:bodyPr>
+          <a:lstStyle/>
+          <a:p>
+            <a:pPr>
+              <a:lnSpc>
+                <a:spcPts val="7470"/>
+              </a:lnSpc>
+              <a:spcBef>
+                <a:spcPts val="0"/>
+              </a:spcBef>
+            </a:pPr>
+            <a:r>
+              <a:rPr sz="6670">
+                <a:solidFill>
+                  <a:srgbClr val="010305"/>
+                </a:solidFill>
+                <a:latin typeface="Geist Medium"/>
+              </a:rPr>
+              <a:t>First message as one statement</a:t>
+            </a:r>
+          </a:p>
+        </p:txBody>
+      </p:sp>
+      <p:pic>
+        <p:nvPicPr>
+          <p:cNvPr id="8" name="Picture 7" descr="poster-placeholder.png"/>
+          <p:cNvPicPr>
+            <a:picLocks noChangeAspect="1"/>
+          </p:cNvPicPr>
+          <p:nvPr/>
+        </p:nvPicPr>
+        <p:blipFill>
+          <a:blip r:embed="rId3"/>
+          <a:stretch>
+            <a:fillRect/>
+          </a:stretch>
+        </p:blipFill>
+        <p:spPr>
+          <a:xfrm>
+            <a:off x="1365292" y="10540561"/>
+            <a:ext cx="12465744" cy="7791090"/>
+          </a:xfrm>
+          <a:prstGeom prst="rect">
+            <a:avLst/>
+          </a:prstGeom>
+        </p:spPr>
+      </p:pic>
+      <p:sp>
+        <p:nvSpPr>
+          <p:cNvPr id="9" name="TextBox 8"/>
+          <p:cNvSpPr txBox="1"/>
+          <p:nvPr/>
+        </p:nvSpPr>
+        <p:spPr>
+          <a:xfrm>
+            <a:off x="1210863" y="18513280"/>
+            <a:ext cx="12774603" cy="714409"/>
+          </a:xfrm>
+          <a:prstGeom prst="rect">
+            <a:avLst/>
+          </a:prstGeom>
+          <a:noFill/>
+        </p:spPr>
+        <p:txBody>
+          <a:bodyPr wrap="square" lIns="0" rIns="0" tIns="0" bIns="0">
+            <a:spAutoFit/>
+          </a:bodyPr>
+          <a:lstStyle/>
+          <a:p>
+            <a:pPr>
+              <a:lnSpc>
+                <a:spcPts val="3840"/>
+              </a:lnSpc>
+              <a:spcBef>
+                <a:spcPts val="0"/>
+              </a:spcBef>
+            </a:pPr>
+            <a:r>
+              <a:rPr sz="3340">
+                <a:solidFill>
+                  <a:srgbClr val="475159"/>
+                </a:solidFill>
+                <a:latin typeface="Geist"/>
+              </a:rPr>
+              <a:t>Author+ YY Journal</a:t>
+            </a:r>
+          </a:p>
+        </p:txBody>
+      </p:sp>
+      <p:pic>
+        <p:nvPicPr>
+          <p:cNvPr id="10" name="Picture 9" descr="poster-placeholder.png"/>
+          <p:cNvPicPr>
+            <a:picLocks noChangeAspect="1"/>
+          </p:cNvPicPr>
+          <p:nvPr/>
+        </p:nvPicPr>
+        <p:blipFill>
+          <a:blip r:embed="rId3"/>
+          <a:stretch>
+            <a:fillRect/>
+          </a:stretch>
+        </p:blipFill>
+        <p:spPr>
+          <a:xfrm>
+            <a:off x="1365292" y="19348775"/>
+            <a:ext cx="12465744" cy="7791090"/>
+          </a:xfrm>
+          <a:prstGeom prst="rect">
+            <a:avLst/>
+          </a:prstGeom>
+        </p:spPr>
+      </p:pic>
+      <p:sp>
+        <p:nvSpPr>
+          <p:cNvPr id="11" name="TextBox 10"/>
+          <p:cNvSpPr txBox="1"/>
+          <p:nvPr/>
+        </p:nvSpPr>
+        <p:spPr>
+          <a:xfrm>
+            <a:off x="1210863" y="27321495"/>
+            <a:ext cx="12774603" cy="714409"/>
+          </a:xfrm>
+          <a:prstGeom prst="rect">
+            <a:avLst/>
+          </a:prstGeom>
+          <a:noFill/>
+        </p:spPr>
+        <p:txBody>
+          <a:bodyPr wrap="square" lIns="0" rIns="0" tIns="0" bIns="0">
+            <a:spAutoFit/>
+          </a:bodyPr>
+          <a:lstStyle/>
+          <a:p>
+            <a:pPr>
+              <a:lnSpc>
+                <a:spcPts val="3840"/>
+              </a:lnSpc>
+              <a:spcBef>
+                <a:spcPts val="0"/>
+              </a:spcBef>
+            </a:pPr>
+            <a:r>
+              <a:rPr sz="3340">
+                <a:solidFill>
+                  <a:srgbClr val="475159"/>
+                </a:solidFill>
+                <a:latin typeface="Geist"/>
+              </a:rPr>
+              <a:t>Second+ YY Journal</a:t>
+            </a:r>
+          </a:p>
+        </p:txBody>
+      </p:sp>
+      <p:sp>
+        <p:nvSpPr>
+          <p:cNvPr id="12" name="Rectangle 11"/>
           <p:cNvSpPr/>
           <p:nvPr/>
         </p:nvSpPr>
@@ -4455,13 +4823,13 @@
       </p:sp>
       <p:sp>
         <p:nvSpPr>
-          <p:cNvPr id="7" name="TextBox 6"/>
+          <p:cNvPr id="13" name="TextBox 12"/>
           <p:cNvSpPr txBox="1"/>
           <p:nvPr/>
         </p:nvSpPr>
         <p:spPr>
           <a:xfrm>
-            <a:off x="1210863" y="6962461"/>
+            <a:off x="15014699" y="6962461"/>
             <a:ext cx="1356166" cy="1695208"/>
           </a:xfrm>
           <a:prstGeom prst="rect">
@@ -4470,33 +4838,41 @@
           <a:noFill/>
         </p:spPr>
         <p:txBody>
-          <a:bodyPr wrap="square" anchor="t" lIns="0" rIns="0" tIns="0" bIns="0">
+          <a:bodyPr wrap="square" lIns="0" rIns="0" tIns="0" bIns="0">
             <a:spAutoFit/>
           </a:bodyPr>
           <a:lstStyle/>
           <a:p>
-            <a:r>
-              <a:rPr sz="12730">
+            <a:pPr>
+              <a:lnSpc>
+                <a:spcPts val="12680"/>
+              </a:lnSpc>
+              <a:spcBef>
+                <a:spcPts val="0"/>
+              </a:spcBef>
+            </a:pPr>
+            <a:r>
+              <a:rPr sz="12680">
                 <a:solidFill>
                   <a:srgbClr val="0072A1"/>
                 </a:solidFill>
                 <a:latin typeface="Geist Light"/>
               </a:rPr>
-              <a:t>1</a:t>
-            </a:r>
-          </a:p>
-        </p:txBody>
-      </p:sp>
-      <p:sp>
-        <p:nvSpPr>
-          <p:cNvPr id="8" name="TextBox 7"/>
+              <a:t>2</a:t>
+            </a:r>
+          </a:p>
+        </p:txBody>
+      </p:sp>
+      <p:sp>
+        <p:nvSpPr>
+          <p:cNvPr id="14" name="TextBox 13"/>
           <p:cNvSpPr txBox="1"/>
           <p:nvPr/>
         </p:nvSpPr>
         <p:spPr>
           <a:xfrm>
-            <a:off x="2567029" y="7174362"/>
-            <a:ext cx="11418436" cy="2203770"/>
+            <a:off x="16370865" y="7174362"/>
+            <a:ext cx="11418436" cy="1754540"/>
           </a:xfrm>
           <a:prstGeom prst="rect">
             <a:avLst/>
@@ -4504,26 +4880,34 @@
           <a:noFill/>
         </p:spPr>
         <p:txBody>
-          <a:bodyPr wrap="square" anchor="t" lIns="0" rIns="0" tIns="0" bIns="0">
+          <a:bodyPr wrap="square" lIns="0" rIns="0" tIns="0" bIns="0">
             <a:spAutoFit/>
           </a:bodyPr>
           <a:lstStyle/>
           <a:p>
-            <a:r>
-              <a:rPr sz="6700">
+            <a:pPr>
+              <a:lnSpc>
+                <a:spcPts val="7470"/>
+              </a:lnSpc>
+              <a:spcBef>
+                <a:spcPts val="0"/>
+              </a:spcBef>
+            </a:pPr>
+            <a:r>
+              <a:rPr sz="6670">
                 <a:solidFill>
                   <a:srgbClr val="010305"/>
                 </a:solidFill>
                 <a:latin typeface="Geist Medium"/>
               </a:rPr>
-              <a:t>First message as one statement</a:t>
+              <a:t>Second message as one statement</a:t>
             </a:r>
           </a:p>
         </p:txBody>
       </p:sp>
       <p:pic>
         <p:nvPicPr>
-          <p:cNvPr id="9" name="Picture 8" descr="image.png"/>
+          <p:cNvPr id="15" name="Picture 14" descr="poster-placeholder.png"/>
           <p:cNvPicPr>
             <a:picLocks noChangeAspect="1"/>
           </p:cNvPicPr>
@@ -4537,8 +4921,8 @@
         </p:blipFill>
         <p:spPr>
           <a:xfrm>
-            <a:off x="1280532" y="10328660"/>
-            <a:ext cx="12635265" cy="7897040"/>
+            <a:off x="15169128" y="10540561"/>
+            <a:ext cx="12465744" cy="7791090"/>
           </a:xfrm>
           <a:prstGeom prst="rect">
             <a:avLst/>
@@ -4547,14 +4931,14 @@
       </p:pic>
       <p:sp>
         <p:nvSpPr>
-          <p:cNvPr id="10" name="TextBox 9"/>
+          <p:cNvPr id="16" name="TextBox 15"/>
           <p:cNvSpPr txBox="1"/>
           <p:nvPr/>
         </p:nvSpPr>
         <p:spPr>
           <a:xfrm>
-            <a:off x="1210863" y="18407330"/>
-            <a:ext cx="12774603" cy="847604"/>
+            <a:off x="15014699" y="18513280"/>
+            <a:ext cx="12774603" cy="714409"/>
           </a:xfrm>
           <a:prstGeom prst="rect">
             <a:avLst/>
@@ -4562,26 +4946,34 @@
           <a:noFill/>
         </p:spPr>
         <p:txBody>
-          <a:bodyPr wrap="square" anchor="t" lIns="0" rIns="0" tIns="0" bIns="0">
+          <a:bodyPr wrap="square" lIns="0" rIns="0" tIns="0" bIns="0">
             <a:spAutoFit/>
           </a:bodyPr>
           <a:lstStyle/>
           <a:p>
-            <a:r>
-              <a:rPr sz="3350">
+            <a:pPr>
+              <a:lnSpc>
+                <a:spcPts val="3840"/>
+              </a:lnSpc>
+              <a:spcBef>
+                <a:spcPts val="0"/>
+              </a:spcBef>
+            </a:pPr>
+            <a:r>
+              <a:rPr sz="3340">
                 <a:solidFill>
                   <a:srgbClr val="475159"/>
                 </a:solidFill>
                 <a:latin typeface="Geist"/>
               </a:rPr>
-              <a:t>Author+ YY Journal</a:t>
+              <a:t>Third+ YY Journal</a:t>
             </a:r>
           </a:p>
         </p:txBody>
       </p:sp>
       <p:pic>
         <p:nvPicPr>
-          <p:cNvPr id="11" name="Picture 10" descr="image.png"/>
+          <p:cNvPr id="17" name="Picture 16" descr="poster-placeholder.png"/>
           <p:cNvPicPr>
             <a:picLocks noChangeAspect="1"/>
           </p:cNvPicPr>
@@ -4595,8 +4987,8 @@
         </p:blipFill>
         <p:spPr>
           <a:xfrm>
-            <a:off x="1280532" y="19242825"/>
-            <a:ext cx="12635265" cy="7897040"/>
+            <a:off x="15169128" y="19348775"/>
+            <a:ext cx="12465744" cy="7791090"/>
           </a:xfrm>
           <a:prstGeom prst="rect">
             <a:avLst/>
@@ -4605,14 +4997,14 @@
       </p:pic>
       <p:sp>
         <p:nvSpPr>
-          <p:cNvPr id="12" name="TextBox 11"/>
+          <p:cNvPr id="18" name="TextBox 17"/>
           <p:cNvSpPr txBox="1"/>
           <p:nvPr/>
         </p:nvSpPr>
         <p:spPr>
           <a:xfrm>
-            <a:off x="1210863" y="27321495"/>
-            <a:ext cx="12774603" cy="847604"/>
+            <a:off x="15014699" y="27321495"/>
+            <a:ext cx="12774603" cy="714409"/>
           </a:xfrm>
           <a:prstGeom prst="rect">
             <a:avLst/>
@@ -4620,26 +5012,34 @@
           <a:noFill/>
         </p:spPr>
         <p:txBody>
-          <a:bodyPr wrap="square" anchor="t" lIns="0" rIns="0" tIns="0" bIns="0">
+          <a:bodyPr wrap="square" lIns="0" rIns="0" tIns="0" bIns="0">
             <a:spAutoFit/>
           </a:bodyPr>
           <a:lstStyle/>
           <a:p>
-            <a:r>
-              <a:rPr sz="3350">
+            <a:pPr>
+              <a:lnSpc>
+                <a:spcPts val="3840"/>
+              </a:lnSpc>
+              <a:spcBef>
+                <a:spcPts val="0"/>
+              </a:spcBef>
+            </a:pPr>
+            <a:r>
+              <a:rPr sz="3340">
                 <a:solidFill>
                   <a:srgbClr val="475159"/>
                 </a:solidFill>
                 <a:latin typeface="Geist"/>
               </a:rPr>
-              <a:t>Author+ YY Journal</a:t>
-            </a:r>
-          </a:p>
-        </p:txBody>
-      </p:sp>
-      <p:sp>
-        <p:nvSpPr>
-          <p:cNvPr id="13" name="Rectangle 12"/>
+              <a:t>Fourth+ YY Journal</a:t>
+            </a:r>
+          </a:p>
+        </p:txBody>
+      </p:sp>
+      <p:sp>
+        <p:nvSpPr>
+          <p:cNvPr id="19" name="Rectangle 18"/>
           <p:cNvSpPr/>
           <p:nvPr/>
         </p:nvSpPr>
@@ -4683,13 +5083,13 @@
       </p:sp>
       <p:sp>
         <p:nvSpPr>
-          <p:cNvPr id="14" name="TextBox 13"/>
+          <p:cNvPr id="20" name="TextBox 19"/>
           <p:cNvSpPr txBox="1"/>
           <p:nvPr/>
         </p:nvSpPr>
         <p:spPr>
           <a:xfrm>
-            <a:off x="15014699" y="6962461"/>
+            <a:off x="28818535" y="6962461"/>
             <a:ext cx="1356166" cy="1695208"/>
           </a:xfrm>
           <a:prstGeom prst="rect">
@@ -4698,33 +5098,41 @@
           <a:noFill/>
         </p:spPr>
         <p:txBody>
-          <a:bodyPr wrap="square" anchor="t" lIns="0" rIns="0" tIns="0" bIns="0">
+          <a:bodyPr wrap="square" lIns="0" rIns="0" tIns="0" bIns="0">
             <a:spAutoFit/>
           </a:bodyPr>
           <a:lstStyle/>
           <a:p>
-            <a:r>
-              <a:rPr sz="12730">
+            <a:pPr>
+              <a:lnSpc>
+                <a:spcPts val="12680"/>
+              </a:lnSpc>
+              <a:spcBef>
+                <a:spcPts val="0"/>
+              </a:spcBef>
+            </a:pPr>
+            <a:r>
+              <a:rPr sz="12680">
                 <a:solidFill>
                   <a:srgbClr val="0072A1"/>
                 </a:solidFill>
                 <a:latin typeface="Geist Light"/>
               </a:rPr>
-              <a:t>2</a:t>
-            </a:r>
-          </a:p>
-        </p:txBody>
-      </p:sp>
-      <p:sp>
-        <p:nvSpPr>
-          <p:cNvPr id="15" name="TextBox 14"/>
+              <a:t>3</a:t>
+            </a:r>
+          </a:p>
+        </p:txBody>
+      </p:sp>
+      <p:sp>
+        <p:nvSpPr>
+          <p:cNvPr id="21" name="TextBox 20"/>
           <p:cNvSpPr txBox="1"/>
           <p:nvPr/>
         </p:nvSpPr>
         <p:spPr>
           <a:xfrm>
-            <a:off x="16370865" y="7174362"/>
-            <a:ext cx="11418436" cy="2203770"/>
+            <a:off x="30174701" y="7174362"/>
+            <a:ext cx="11418436" cy="1754540"/>
           </a:xfrm>
           <a:prstGeom prst="rect">
             <a:avLst/>
@@ -4732,26 +5140,34 @@
           <a:noFill/>
         </p:spPr>
         <p:txBody>
-          <a:bodyPr wrap="square" anchor="t" lIns="0" rIns="0" tIns="0" bIns="0">
+          <a:bodyPr wrap="square" lIns="0" rIns="0" tIns="0" bIns="0">
             <a:spAutoFit/>
           </a:bodyPr>
           <a:lstStyle/>
           <a:p>
-            <a:r>
-              <a:rPr sz="6700">
+            <a:pPr>
+              <a:lnSpc>
+                <a:spcPts val="7470"/>
+              </a:lnSpc>
+              <a:spcBef>
+                <a:spcPts val="0"/>
+              </a:spcBef>
+            </a:pPr>
+            <a:r>
+              <a:rPr sz="6670">
                 <a:solidFill>
                   <a:srgbClr val="010305"/>
                 </a:solidFill>
                 <a:latin typeface="Geist Medium"/>
               </a:rPr>
-              <a:t>Second message as one statement</a:t>
+              <a:t>Third message as one statement</a:t>
             </a:r>
           </a:p>
         </p:txBody>
       </p:sp>
       <p:pic>
         <p:nvPicPr>
-          <p:cNvPr id="16" name="Picture 15" descr="image.png"/>
+          <p:cNvPr id="22" name="Picture 21" descr="poster-placeholder.png"/>
           <p:cNvPicPr>
             <a:picLocks noChangeAspect="1"/>
           </p:cNvPicPr>
@@ -4765,8 +5181,8 @@
         </p:blipFill>
         <p:spPr>
           <a:xfrm>
-            <a:off x="15084368" y="10328660"/>
-            <a:ext cx="12635265" cy="7897040"/>
+            <a:off x="28972964" y="10540561"/>
+            <a:ext cx="12465744" cy="7791090"/>
           </a:xfrm>
           <a:prstGeom prst="rect">
             <a:avLst/>
@@ -4775,14 +5191,14 @@
       </p:pic>
       <p:sp>
         <p:nvSpPr>
-          <p:cNvPr id="17" name="TextBox 16"/>
+          <p:cNvPr id="23" name="TextBox 22"/>
           <p:cNvSpPr txBox="1"/>
           <p:nvPr/>
         </p:nvSpPr>
         <p:spPr>
           <a:xfrm>
-            <a:off x="15014699" y="18407330"/>
-            <a:ext cx="12774603" cy="847604"/>
+            <a:off x="28818535" y="18513280"/>
+            <a:ext cx="12774603" cy="714409"/>
           </a:xfrm>
           <a:prstGeom prst="rect">
             <a:avLst/>
@@ -4790,26 +5206,34 @@
           <a:noFill/>
         </p:spPr>
         <p:txBody>
-          <a:bodyPr wrap="square" anchor="t" lIns="0" rIns="0" tIns="0" bIns="0">
+          <a:bodyPr wrap="square" lIns="0" rIns="0" tIns="0" bIns="0">
             <a:spAutoFit/>
           </a:bodyPr>
           <a:lstStyle/>
           <a:p>
-            <a:r>
-              <a:rPr sz="3350">
+            <a:pPr>
+              <a:lnSpc>
+                <a:spcPts val="3840"/>
+              </a:lnSpc>
+              <a:spcBef>
+                <a:spcPts val="0"/>
+              </a:spcBef>
+            </a:pPr>
+            <a:r>
+              <a:rPr sz="3340">
                 <a:solidFill>
                   <a:srgbClr val="475159"/>
                 </a:solidFill>
                 <a:latin typeface="Geist"/>
               </a:rPr>
-              <a:t>Author+ YY Journal</a:t>
+              <a:t>Fifth+ YY Journal</a:t>
             </a:r>
           </a:p>
         </p:txBody>
       </p:sp>
       <p:pic>
         <p:nvPicPr>
-          <p:cNvPr id="18" name="Picture 17" descr="image.png"/>
+          <p:cNvPr id="24" name="Picture 23" descr="poster-placeholder.png"/>
           <p:cNvPicPr>
             <a:picLocks noChangeAspect="1"/>
           </p:cNvPicPr>
@@ -4823,8 +5247,8 @@
         </p:blipFill>
         <p:spPr>
           <a:xfrm>
-            <a:off x="15084368" y="19242825"/>
-            <a:ext cx="12635265" cy="7897040"/>
+            <a:off x="28972964" y="19348775"/>
+            <a:ext cx="12465744" cy="7791090"/>
           </a:xfrm>
           <a:prstGeom prst="rect">
             <a:avLst/>
@@ -4833,14 +5257,14 @@
       </p:pic>
       <p:sp>
         <p:nvSpPr>
-          <p:cNvPr id="19" name="TextBox 18"/>
+          <p:cNvPr id="25" name="TextBox 24"/>
           <p:cNvSpPr txBox="1"/>
           <p:nvPr/>
         </p:nvSpPr>
         <p:spPr>
           <a:xfrm>
-            <a:off x="15014699" y="27321495"/>
-            <a:ext cx="12774603" cy="847604"/>
+            <a:off x="28818535" y="27321495"/>
+            <a:ext cx="12774603" cy="714409"/>
           </a:xfrm>
           <a:prstGeom prst="rect">
             <a:avLst/>
@@ -4848,203 +5272,27 @@
           <a:noFill/>
         </p:spPr>
         <p:txBody>
-          <a:bodyPr wrap="square" anchor="t" lIns="0" rIns="0" tIns="0" bIns="0">
+          <a:bodyPr wrap="square" lIns="0" rIns="0" tIns="0" bIns="0">
             <a:spAutoFit/>
           </a:bodyPr>
           <a:lstStyle/>
           <a:p>
-            <a:r>
-              <a:rPr sz="3350">
+            <a:pPr>
+              <a:lnSpc>
+                <a:spcPts val="3840"/>
+              </a:lnSpc>
+              <a:spcBef>
+                <a:spcPts val="0"/>
+              </a:spcBef>
+            </a:pPr>
+            <a:r>
+              <a:rPr sz="3340">
                 <a:solidFill>
                   <a:srgbClr val="475159"/>
                 </a:solidFill>
                 <a:latin typeface="Geist"/>
               </a:rPr>
-              <a:t>Author+ YY Journal</a:t>
-            </a:r>
-          </a:p>
-        </p:txBody>
-      </p:sp>
-      <p:sp>
-        <p:nvSpPr>
-          <p:cNvPr id="20" name="TextBox 19"/>
-          <p:cNvSpPr txBox="1"/>
-          <p:nvPr/>
-        </p:nvSpPr>
-        <p:spPr>
-          <a:xfrm>
-            <a:off x="28818535" y="6962461"/>
-            <a:ext cx="1356166" cy="1695208"/>
-          </a:xfrm>
-          <a:prstGeom prst="rect">
-            <a:avLst/>
-          </a:prstGeom>
-          <a:noFill/>
-        </p:spPr>
-        <p:txBody>
-          <a:bodyPr wrap="square" anchor="t" lIns="0" rIns="0" tIns="0" bIns="0">
-            <a:spAutoFit/>
-          </a:bodyPr>
-          <a:lstStyle/>
-          <a:p>
-            <a:r>
-              <a:rPr sz="12730">
-                <a:solidFill>
-                  <a:srgbClr val="0072A1"/>
-                </a:solidFill>
-                <a:latin typeface="Geist Light"/>
-              </a:rPr>
-              <a:t>3</a:t>
-            </a:r>
-          </a:p>
-        </p:txBody>
-      </p:sp>
-      <p:sp>
-        <p:nvSpPr>
-          <p:cNvPr id="21" name="TextBox 20"/>
-          <p:cNvSpPr txBox="1"/>
-          <p:nvPr/>
-        </p:nvSpPr>
-        <p:spPr>
-          <a:xfrm>
-            <a:off x="30174701" y="7174362"/>
-            <a:ext cx="11418436" cy="2203770"/>
-          </a:xfrm>
-          <a:prstGeom prst="rect">
-            <a:avLst/>
-          </a:prstGeom>
-          <a:noFill/>
-        </p:spPr>
-        <p:txBody>
-          <a:bodyPr wrap="square" anchor="t" lIns="0" rIns="0" tIns="0" bIns="0">
-            <a:spAutoFit/>
-          </a:bodyPr>
-          <a:lstStyle/>
-          <a:p>
-            <a:r>
-              <a:rPr sz="6700">
-                <a:solidFill>
-                  <a:srgbClr val="010305"/>
-                </a:solidFill>
-                <a:latin typeface="Geist Medium"/>
-              </a:rPr>
-              <a:t>Third message as one statement</a:t>
-            </a:r>
-          </a:p>
-        </p:txBody>
-      </p:sp>
-      <p:pic>
-        <p:nvPicPr>
-          <p:cNvPr id="22" name="Picture 21" descr="image.png"/>
-          <p:cNvPicPr>
-            <a:picLocks noChangeAspect="1"/>
-          </p:cNvPicPr>
-          <p:nvPr/>
-        </p:nvPicPr>
-        <p:blipFill>
-          <a:blip r:embed="rId3"/>
-          <a:stretch>
-            <a:fillRect/>
-          </a:stretch>
-        </p:blipFill>
-        <p:spPr>
-          <a:xfrm>
-            <a:off x="28888204" y="10328660"/>
-            <a:ext cx="12635265" cy="7897040"/>
-          </a:xfrm>
-          <a:prstGeom prst="rect">
-            <a:avLst/>
-          </a:prstGeom>
-        </p:spPr>
-      </p:pic>
-      <p:sp>
-        <p:nvSpPr>
-          <p:cNvPr id="23" name="TextBox 22"/>
-          <p:cNvSpPr txBox="1"/>
-          <p:nvPr/>
-        </p:nvSpPr>
-        <p:spPr>
-          <a:xfrm>
-            <a:off x="28818535" y="18407330"/>
-            <a:ext cx="12774603" cy="847604"/>
-          </a:xfrm>
-          <a:prstGeom prst="rect">
-            <a:avLst/>
-          </a:prstGeom>
-          <a:noFill/>
-        </p:spPr>
-        <p:txBody>
-          <a:bodyPr wrap="square" anchor="t" lIns="0" rIns="0" tIns="0" bIns="0">
-            <a:spAutoFit/>
-          </a:bodyPr>
-          <a:lstStyle/>
-          <a:p>
-            <a:r>
-              <a:rPr sz="3350">
-                <a:solidFill>
-                  <a:srgbClr val="475159"/>
-                </a:solidFill>
-                <a:latin typeface="Geist"/>
-              </a:rPr>
-              <a:t>Author+ YY Journal</a:t>
-            </a:r>
-          </a:p>
-        </p:txBody>
-      </p:sp>
-      <p:pic>
-        <p:nvPicPr>
-          <p:cNvPr id="24" name="Picture 23" descr="image.png"/>
-          <p:cNvPicPr>
-            <a:picLocks noChangeAspect="1"/>
-          </p:cNvPicPr>
-          <p:nvPr/>
-        </p:nvPicPr>
-        <p:blipFill>
-          <a:blip r:embed="rId3"/>
-          <a:stretch>
-            <a:fillRect/>
-          </a:stretch>
-        </p:blipFill>
-        <p:spPr>
-          <a:xfrm>
-            <a:off x="28888204" y="19242825"/>
-            <a:ext cx="12635265" cy="7897040"/>
-          </a:xfrm>
-          <a:prstGeom prst="rect">
-            <a:avLst/>
-          </a:prstGeom>
-        </p:spPr>
-      </p:pic>
-      <p:sp>
-        <p:nvSpPr>
-          <p:cNvPr id="25" name="TextBox 24"/>
-          <p:cNvSpPr txBox="1"/>
-          <p:nvPr/>
-        </p:nvSpPr>
-        <p:spPr>
-          <a:xfrm>
-            <a:off x="28818535" y="27321495"/>
-            <a:ext cx="12774603" cy="847604"/>
-          </a:xfrm>
-          <a:prstGeom prst="rect">
-            <a:avLst/>
-          </a:prstGeom>
-          <a:noFill/>
-        </p:spPr>
-        <p:txBody>
-          <a:bodyPr wrap="square" anchor="t" lIns="0" rIns="0" tIns="0" bIns="0">
-            <a:spAutoFit/>
-          </a:bodyPr>
-          <a:lstStyle/>
-          <a:p>
-            <a:r>
-              <a:rPr sz="3350">
-                <a:solidFill>
-                  <a:srgbClr val="475159"/>
-                </a:solidFill>
-                <a:latin typeface="Geist"/>
-              </a:rPr>
-              <a:t>Author+ YY Journal</a:t>
+              <a:t>Sixth+ YY Journal</a:t>
             </a:r>
           </a:p>
         </p:txBody>
@@ -5057,8 +5305,8 @@
         </p:nvSpPr>
         <p:spPr>
           <a:xfrm>
-            <a:off x="1210863" y="28871399"/>
-            <a:ext cx="40382274" cy="678083"/>
+            <a:off x="1210863" y="28990064"/>
+            <a:ext cx="40382274" cy="559419"/>
           </a:xfrm>
           <a:prstGeom prst="rect">
             <a:avLst/>
@@ -5066,13 +5314,21 @@
           <a:noFill/>
         </p:spPr>
         <p:txBody>
-          <a:bodyPr wrap="square" anchor="b" lIns="0" rIns="0" tIns="0" bIns="0">
+          <a:bodyPr wrap="square" lIns="0" rIns="0" tIns="0" bIns="0">
             <a:spAutoFit/>
           </a:bodyPr>
           <a:lstStyle/>
           <a:p>
-            <a:r>
-              <a:rPr sz="3850">
+            <a:pPr>
+              <a:lnSpc>
+                <a:spcPts val="4410"/>
+              </a:lnSpc>
+              <a:spcBef>
+                <a:spcPts val="0"/>
+              </a:spcBef>
+            </a:pPr>
+            <a:r>
+              <a:rPr sz="3840">
                 <a:solidFill>
                   <a:srgbClr val="475159"/>
                 </a:solidFill>

</xml_diff>